<commit_message>
Update documentation to remove outdated images and clarify installation instructions for the Gture SaaS platform. Enhance the quick-start guide with detailed explanations of the agent lifecycle, including the distinctions between agent templates, deployed agents, and activated agents. This improves user understanding of the platform's features and streamlines the onboarding process.
</commit_message>
<xml_diff>
--- a/docs/assets/illustrations.pptx
+++ b/docs/assets/illustrations.pptx
@@ -265,7 +265,7 @@
           <a:p>
             <a:fld id="{B6EBD849-BF62-3E41-9392-B52349D77D8A}" type="datetimeFigureOut">
               <a:rPr lang="en-US" smtClean="0"/>
-              <a:t>1/23/26</a:t>
+              <a:t>7/11/26</a:t>
             </a:fld>
             <a:endParaRPr lang="en-US"/>
           </a:p>
@@ -463,7 +463,7 @@
           <a:p>
             <a:fld id="{B6EBD849-BF62-3E41-9392-B52349D77D8A}" type="datetimeFigureOut">
               <a:rPr lang="en-US" smtClean="0"/>
-              <a:t>1/23/26</a:t>
+              <a:t>7/11/26</a:t>
             </a:fld>
             <a:endParaRPr lang="en-US"/>
           </a:p>
@@ -671,7 +671,7 @@
           <a:p>
             <a:fld id="{B6EBD849-BF62-3E41-9392-B52349D77D8A}" type="datetimeFigureOut">
               <a:rPr lang="en-US" smtClean="0"/>
-              <a:t>1/23/26</a:t>
+              <a:t>7/11/26</a:t>
             </a:fld>
             <a:endParaRPr lang="en-US"/>
           </a:p>
@@ -869,7 +869,7 @@
           <a:p>
             <a:fld id="{B6EBD849-BF62-3E41-9392-B52349D77D8A}" type="datetimeFigureOut">
               <a:rPr lang="en-US" smtClean="0"/>
-              <a:t>1/23/26</a:t>
+              <a:t>7/11/26</a:t>
             </a:fld>
             <a:endParaRPr lang="en-US"/>
           </a:p>
@@ -1144,7 +1144,7 @@
           <a:p>
             <a:fld id="{B6EBD849-BF62-3E41-9392-B52349D77D8A}" type="datetimeFigureOut">
               <a:rPr lang="en-US" smtClean="0"/>
-              <a:t>1/23/26</a:t>
+              <a:t>7/11/26</a:t>
             </a:fld>
             <a:endParaRPr lang="en-US"/>
           </a:p>
@@ -1409,7 +1409,7 @@
           <a:p>
             <a:fld id="{B6EBD849-BF62-3E41-9392-B52349D77D8A}" type="datetimeFigureOut">
               <a:rPr lang="en-US" smtClean="0"/>
-              <a:t>1/23/26</a:t>
+              <a:t>7/11/26</a:t>
             </a:fld>
             <a:endParaRPr lang="en-US"/>
           </a:p>
@@ -1821,7 +1821,7 @@
           <a:p>
             <a:fld id="{B6EBD849-BF62-3E41-9392-B52349D77D8A}" type="datetimeFigureOut">
               <a:rPr lang="en-US" smtClean="0"/>
-              <a:t>1/23/26</a:t>
+              <a:t>7/11/26</a:t>
             </a:fld>
             <a:endParaRPr lang="en-US"/>
           </a:p>
@@ -1962,7 +1962,7 @@
           <a:p>
             <a:fld id="{B6EBD849-BF62-3E41-9392-B52349D77D8A}" type="datetimeFigureOut">
               <a:rPr lang="en-US" smtClean="0"/>
-              <a:t>1/23/26</a:t>
+              <a:t>7/11/26</a:t>
             </a:fld>
             <a:endParaRPr lang="en-US"/>
           </a:p>
@@ -2075,7 +2075,7 @@
           <a:p>
             <a:fld id="{B6EBD849-BF62-3E41-9392-B52349D77D8A}" type="datetimeFigureOut">
               <a:rPr lang="en-US" smtClean="0"/>
-              <a:t>1/23/26</a:t>
+              <a:t>7/11/26</a:t>
             </a:fld>
             <a:endParaRPr lang="en-US"/>
           </a:p>
@@ -2386,7 +2386,7 @@
           <a:p>
             <a:fld id="{B6EBD849-BF62-3E41-9392-B52349D77D8A}" type="datetimeFigureOut">
               <a:rPr lang="en-US" smtClean="0"/>
-              <a:t>1/23/26</a:t>
+              <a:t>7/11/26</a:t>
             </a:fld>
             <a:endParaRPr lang="en-US"/>
           </a:p>
@@ -2674,7 +2674,7 @@
           <a:p>
             <a:fld id="{B6EBD849-BF62-3E41-9392-B52349D77D8A}" type="datetimeFigureOut">
               <a:rPr lang="en-US" smtClean="0"/>
-              <a:t>1/23/26</a:t>
+              <a:t>7/11/26</a:t>
             </a:fld>
             <a:endParaRPr lang="en-US"/>
           </a:p>
@@ -2915,7 +2915,7 @@
           <a:p>
             <a:fld id="{B6EBD849-BF62-3E41-9392-B52349D77D8A}" type="datetimeFigureOut">
               <a:rPr lang="en-US" smtClean="0"/>
-              <a:t>1/23/26</a:t>
+              <a:t>7/11/26</a:t>
             </a:fld>
             <a:endParaRPr lang="en-US"/>
           </a:p>
@@ -3401,10 +3401,10 @@
           <p:nvPr/>
         </p:nvPicPr>
         <p:blipFill>
-          <a:blip r:embed="rId2">
+          <a:blip>
             <a:extLst>
               <a:ext uri="{96DAC541-7B7A-43D3-8B79-37D633B846F1}">
-                <asvg:svgBlip xmlns:asvg="http://schemas.microsoft.com/office/drawing/2016/SVG/main" r:embed="rId3"/>
+                <asvg:svgBlip xmlns:asvg="http://schemas.microsoft.com/office/drawing/2016/SVG/main" r:embed="rId2"/>
               </a:ext>
             </a:extLst>
           </a:blip>
@@ -3478,10 +3478,10 @@
           <p:nvPr/>
         </p:nvPicPr>
         <p:blipFill>
-          <a:blip r:embed="rId4">
+          <a:blip>
             <a:extLst>
               <a:ext uri="{96DAC541-7B7A-43D3-8B79-37D633B846F1}">
-                <asvg:svgBlip xmlns:asvg="http://schemas.microsoft.com/office/drawing/2016/SVG/main" r:embed="rId5"/>
+                <asvg:svgBlip xmlns:asvg="http://schemas.microsoft.com/office/drawing/2016/SVG/main" r:embed="rId3"/>
               </a:ext>
             </a:extLst>
           </a:blip>
@@ -3514,10 +3514,10 @@
           <p:nvPr/>
         </p:nvPicPr>
         <p:blipFill>
-          <a:blip r:embed="rId6">
+          <a:blip>
             <a:extLst>
               <a:ext uri="{96DAC541-7B7A-43D3-8B79-37D633B846F1}">
-                <asvg:svgBlip xmlns:asvg="http://schemas.microsoft.com/office/drawing/2016/SVG/main" r:embed="rId7"/>
+                <asvg:svgBlip xmlns:asvg="http://schemas.microsoft.com/office/drawing/2016/SVG/main" r:embed="rId4"/>
               </a:ext>
             </a:extLst>
           </a:blip>
@@ -3550,10 +3550,10 @@
           <p:nvPr/>
         </p:nvPicPr>
         <p:blipFill>
-          <a:blip r:embed="rId8">
+          <a:blip>
             <a:extLst>
               <a:ext uri="{96DAC541-7B7A-43D3-8B79-37D633B846F1}">
-                <asvg:svgBlip xmlns:asvg="http://schemas.microsoft.com/office/drawing/2016/SVG/main" r:embed="rId9"/>
+                <asvg:svgBlip xmlns:asvg="http://schemas.microsoft.com/office/drawing/2016/SVG/main" r:embed="rId5"/>
               </a:ext>
             </a:extLst>
           </a:blip>
@@ -3586,10 +3586,10 @@
           <p:nvPr/>
         </p:nvPicPr>
         <p:blipFill>
-          <a:blip r:embed="rId10">
+          <a:blip>
             <a:extLst>
               <a:ext uri="{96DAC541-7B7A-43D3-8B79-37D633B846F1}">
-                <asvg:svgBlip xmlns:asvg="http://schemas.microsoft.com/office/drawing/2016/SVG/main" r:embed="rId11"/>
+                <asvg:svgBlip xmlns:asvg="http://schemas.microsoft.com/office/drawing/2016/SVG/main" r:embed="rId6"/>
               </a:ext>
             </a:extLst>
           </a:blip>
@@ -3622,10 +3622,10 @@
           <p:nvPr/>
         </p:nvPicPr>
         <p:blipFill>
-          <a:blip r:embed="rId10">
+          <a:blip>
             <a:extLst>
               <a:ext uri="{96DAC541-7B7A-43D3-8B79-37D633B846F1}">
-                <asvg:svgBlip xmlns:asvg="http://schemas.microsoft.com/office/drawing/2016/SVG/main" r:embed="rId11"/>
+                <asvg:svgBlip xmlns:asvg="http://schemas.microsoft.com/office/drawing/2016/SVG/main" r:embed="rId6"/>
               </a:ext>
             </a:extLst>
           </a:blip>
@@ -3878,10 +3878,10 @@
           <p:nvPr/>
         </p:nvPicPr>
         <p:blipFill>
-          <a:blip r:embed="rId12">
+          <a:blip>
             <a:extLst>
               <a:ext uri="{96DAC541-7B7A-43D3-8B79-37D633B846F1}">
-                <asvg:svgBlip xmlns:asvg="http://schemas.microsoft.com/office/drawing/2016/SVG/main" r:embed="rId13"/>
+                <asvg:svgBlip xmlns:asvg="http://schemas.microsoft.com/office/drawing/2016/SVG/main" r:embed="rId7"/>
               </a:ext>
             </a:extLst>
           </a:blip>
@@ -3914,10 +3914,10 @@
           <p:nvPr/>
         </p:nvPicPr>
         <p:blipFill>
-          <a:blip r:embed="rId12">
+          <a:blip>
             <a:extLst>
               <a:ext uri="{96DAC541-7B7A-43D3-8B79-37D633B846F1}">
-                <asvg:svgBlip xmlns:asvg="http://schemas.microsoft.com/office/drawing/2016/SVG/main" r:embed="rId13"/>
+                <asvg:svgBlip xmlns:asvg="http://schemas.microsoft.com/office/drawing/2016/SVG/main" r:embed="rId7"/>
               </a:ext>
             </a:extLst>
           </a:blip>
@@ -4125,8 +4125,8 @@
         </p:nvSpPr>
         <p:spPr>
           <a:xfrm>
-            <a:off x="4400707" y="1063492"/>
-            <a:ext cx="1936376" cy="369332"/>
+            <a:off x="4195428" y="1079500"/>
+            <a:ext cx="2346934" cy="369332"/>
           </a:xfrm>
           <a:prstGeom prst="rect">
             <a:avLst/>
@@ -4147,7 +4147,7 @@
                 </a:solidFill>
                 <a:latin typeface="Avenir Book" panose="02000503020000020003" pitchFamily="2" charset="0"/>
               </a:rPr>
-              <a:t>Your Web Server</a:t>
+              <a:t>Your Product BFF</a:t>
             </a:r>
           </a:p>
         </p:txBody>
@@ -4312,10 +4312,10 @@
           <p:nvPr/>
         </p:nvPicPr>
         <p:blipFill>
-          <a:blip r:embed="rId2">
+          <a:blip>
             <a:extLst>
               <a:ext uri="{96DAC541-7B7A-43D3-8B79-37D633B846F1}">
-                <asvg:svgBlip xmlns:asvg="http://schemas.microsoft.com/office/drawing/2016/SVG/main" r:embed="rId3"/>
+                <asvg:svgBlip xmlns:asvg="http://schemas.microsoft.com/office/drawing/2016/SVG/main" r:embed="rId2"/>
               </a:ext>
             </a:extLst>
           </a:blip>
@@ -4348,10 +4348,10 @@
           <p:nvPr/>
         </p:nvPicPr>
         <p:blipFill>
-          <a:blip r:embed="rId4">
+          <a:blip>
             <a:extLst>
               <a:ext uri="{96DAC541-7B7A-43D3-8B79-37D633B846F1}">
-                <asvg:svgBlip xmlns:asvg="http://schemas.microsoft.com/office/drawing/2016/SVG/main" r:embed="rId5"/>
+                <asvg:svgBlip xmlns:asvg="http://schemas.microsoft.com/office/drawing/2016/SVG/main" r:embed="rId3"/>
               </a:ext>
             </a:extLst>
           </a:blip>
@@ -4384,10 +4384,10 @@
           <p:nvPr/>
         </p:nvPicPr>
         <p:blipFill>
-          <a:blip r:embed="rId6">
+          <a:blip>
             <a:extLst>
               <a:ext uri="{96DAC541-7B7A-43D3-8B79-37D633B846F1}">
-                <asvg:svgBlip xmlns:asvg="http://schemas.microsoft.com/office/drawing/2016/SVG/main" r:embed="rId7"/>
+                <asvg:svgBlip xmlns:asvg="http://schemas.microsoft.com/office/drawing/2016/SVG/main" r:embed="rId4"/>
               </a:ext>
             </a:extLst>
           </a:blip>
@@ -4420,10 +4420,10 @@
           <p:nvPr/>
         </p:nvPicPr>
         <p:blipFill>
-          <a:blip r:embed="rId8">
+          <a:blip>
             <a:extLst>
               <a:ext uri="{96DAC541-7B7A-43D3-8B79-37D633B846F1}">
-                <asvg:svgBlip xmlns:asvg="http://schemas.microsoft.com/office/drawing/2016/SVG/main" r:embed="rId9"/>
+                <asvg:svgBlip xmlns:asvg="http://schemas.microsoft.com/office/drawing/2016/SVG/main" r:embed="rId5"/>
               </a:ext>
             </a:extLst>
           </a:blip>
@@ -4456,10 +4456,10 @@
           <p:nvPr/>
         </p:nvPicPr>
         <p:blipFill>
-          <a:blip r:embed="rId8">
+          <a:blip>
             <a:extLst>
               <a:ext uri="{96DAC541-7B7A-43D3-8B79-37D633B846F1}">
-                <asvg:svgBlip xmlns:asvg="http://schemas.microsoft.com/office/drawing/2016/SVG/main" r:embed="rId9"/>
+                <asvg:svgBlip xmlns:asvg="http://schemas.microsoft.com/office/drawing/2016/SVG/main" r:embed="rId5"/>
               </a:ext>
             </a:extLst>
           </a:blip>
@@ -4668,7 +4668,7 @@
         </p:nvCxnSpPr>
         <p:spPr>
           <a:xfrm>
-            <a:off x="9186530" y="2501355"/>
+            <a:off x="9186530" y="2655305"/>
             <a:ext cx="691117" cy="0"/>
           </a:xfrm>
           <a:prstGeom prst="straightConnector1">
@@ -4712,10 +4712,10 @@
           <p:nvPr/>
         </p:nvPicPr>
         <p:blipFill>
-          <a:blip r:embed="rId10">
+          <a:blip>
             <a:extLst>
               <a:ext uri="{96DAC541-7B7A-43D3-8B79-37D633B846F1}">
-                <asvg:svgBlip xmlns:asvg="http://schemas.microsoft.com/office/drawing/2016/SVG/main" r:embed="rId11"/>
+                <asvg:svgBlip xmlns:asvg="http://schemas.microsoft.com/office/drawing/2016/SVG/main" r:embed="rId6"/>
               </a:ext>
             </a:extLst>
           </a:blip>
@@ -4748,10 +4748,10 @@
           <p:nvPr/>
         </p:nvPicPr>
         <p:blipFill>
-          <a:blip r:embed="rId10">
+          <a:blip>
             <a:extLst>
               <a:ext uri="{96DAC541-7B7A-43D3-8B79-37D633B846F1}">
-                <asvg:svgBlip xmlns:asvg="http://schemas.microsoft.com/office/drawing/2016/SVG/main" r:embed="rId11"/>
+                <asvg:svgBlip xmlns:asvg="http://schemas.microsoft.com/office/drawing/2016/SVG/main" r:embed="rId6"/>
               </a:ext>
             </a:extLst>
           </a:blip>
@@ -4960,7 +4960,7 @@
         <p:spPr>
           <a:xfrm>
             <a:off x="4400707" y="1797145"/>
-            <a:ext cx="1936376" cy="369332"/>
+            <a:ext cx="1936376" cy="276999"/>
           </a:xfrm>
           <a:prstGeom prst="rect">
             <a:avLst/>
@@ -4975,7 +4975,7 @@
           <a:p>
             <a:pPr algn="ctr"/>
             <a:r>
-              <a:rPr lang="en-US" dirty="0">
+              <a:rPr lang="en-US" sz="1200" dirty="0">
                 <a:solidFill>
                   <a:schemeClr val="bg1"/>
                 </a:solidFill>
@@ -5051,12 +5051,132 @@
           </a:p>
         </p:txBody>
       </p:sp>
-      <p:sp>
-        <p:nvSpPr>
-          <p:cNvPr id="9" name="Rounded Rectangle 8">
-            <a:extLst>
-              <a:ext uri="{FF2B5EF4-FFF2-40B4-BE49-F238E27FC236}">
-                <a16:creationId xmlns:a16="http://schemas.microsoft.com/office/drawing/2014/main" id="{3473AE74-70CF-8DBB-9A11-737D27173566}"/>
+      <p:cxnSp>
+        <p:nvCxnSpPr>
+          <p:cNvPr id="21" name="Straight Arrow Connector 20">
+            <a:extLst>
+              <a:ext uri="{FF2B5EF4-FFF2-40B4-BE49-F238E27FC236}">
+                <a16:creationId xmlns:a16="http://schemas.microsoft.com/office/drawing/2014/main" id="{F3B1EEF8-D976-3222-1850-BD993F1C4B63}"/>
+              </a:ext>
+            </a:extLst>
+          </p:cNvPr>
+          <p:cNvCxnSpPr/>
+          <p:nvPr/>
+        </p:nvCxnSpPr>
+        <p:spPr>
+          <a:xfrm>
+            <a:off x="2048438" y="2676433"/>
+            <a:ext cx="2701892" cy="0"/>
+          </a:xfrm>
+          <a:prstGeom prst="straightConnector1">
+            <a:avLst/>
+          </a:prstGeom>
+          <a:ln>
+            <a:solidFill>
+              <a:schemeClr val="bg1"/>
+            </a:solidFill>
+            <a:headEnd type="triangle"/>
+            <a:tailEnd type="triangle"/>
+          </a:ln>
+        </p:spPr>
+        <p:style>
+          <a:lnRef idx="2">
+            <a:schemeClr val="accent1"/>
+          </a:lnRef>
+          <a:fillRef idx="0">
+            <a:schemeClr val="accent1"/>
+          </a:fillRef>
+          <a:effectRef idx="1">
+            <a:schemeClr val="accent1"/>
+          </a:effectRef>
+          <a:fontRef idx="minor">
+            <a:schemeClr val="tx1"/>
+          </a:fontRef>
+        </p:style>
+      </p:cxnSp>
+      <p:pic>
+        <p:nvPicPr>
+          <p:cNvPr id="23" name="Graphic 22" descr="Ui Ux with solid fill">
+            <a:extLst>
+              <a:ext uri="{FF2B5EF4-FFF2-40B4-BE49-F238E27FC236}">
+                <a16:creationId xmlns:a16="http://schemas.microsoft.com/office/drawing/2014/main" id="{7585C4C5-A7E8-8C9B-DAC3-F27498D39667}"/>
+              </a:ext>
+            </a:extLst>
+          </p:cNvPr>
+          <p:cNvPicPr>
+            <a:picLocks noChangeAspect="1"/>
+          </p:cNvPicPr>
+          <p:nvPr/>
+        </p:nvPicPr>
+        <p:blipFill>
+          <a:blip>
+            <a:extLst>
+              <a:ext uri="{96DAC541-7B7A-43D3-8B79-37D633B846F1}">
+                <asvg:svgBlip xmlns:asvg="http://schemas.microsoft.com/office/drawing/2016/SVG/main" r:embed="rId7"/>
+              </a:ext>
+            </a:extLst>
+          </a:blip>
+          <a:stretch>
+            <a:fillRect/>
+          </a:stretch>
+        </p:blipFill>
+        <p:spPr>
+          <a:xfrm>
+            <a:off x="590705" y="2095009"/>
+            <a:ext cx="1237130" cy="1237130"/>
+          </a:xfrm>
+          <a:prstGeom prst="rect">
+            <a:avLst/>
+          </a:prstGeom>
+        </p:spPr>
+      </p:pic>
+      <p:sp>
+        <p:nvSpPr>
+          <p:cNvPr id="28" name="TextBox 27">
+            <a:extLst>
+              <a:ext uri="{FF2B5EF4-FFF2-40B4-BE49-F238E27FC236}">
+                <a16:creationId xmlns:a16="http://schemas.microsoft.com/office/drawing/2014/main" id="{5F3F082B-58F4-B7B2-9447-C2211B32FB7C}"/>
+              </a:ext>
+            </a:extLst>
+          </p:cNvPr>
+          <p:cNvSpPr txBox="1"/>
+          <p:nvPr/>
+        </p:nvSpPr>
+        <p:spPr>
+          <a:xfrm>
+            <a:off x="241082" y="3294997"/>
+            <a:ext cx="1936376" cy="276999"/>
+          </a:xfrm>
+          <a:prstGeom prst="rect">
+            <a:avLst/>
+          </a:prstGeom>
+          <a:noFill/>
+        </p:spPr>
+        <p:txBody>
+          <a:bodyPr wrap="square" rtlCol="0">
+            <a:spAutoFit/>
+          </a:bodyPr>
+          <a:lstStyle/>
+          <a:p>
+            <a:pPr algn="ctr"/>
+            <a:r>
+              <a:rPr lang="en-US" sz="1200" dirty="0">
+                <a:solidFill>
+                  <a:schemeClr val="bg1"/>
+                </a:solidFill>
+                <a:latin typeface="Avenir Book" panose="02000503020000020003" pitchFamily="2" charset="0"/>
+              </a:rPr>
+              <a:t>Your Product UI</a:t>
+            </a:r>
+          </a:p>
+        </p:txBody>
+      </p:sp>
+      <p:sp>
+        <p:nvSpPr>
+          <p:cNvPr id="29" name="Rounded Rectangle 28">
+            <a:extLst>
+              <a:ext uri="{FF2B5EF4-FFF2-40B4-BE49-F238E27FC236}">
+                <a16:creationId xmlns:a16="http://schemas.microsoft.com/office/drawing/2014/main" id="{5F2C60D7-94D4-FB7B-FC32-EDE8E37E900C}"/>
               </a:ext>
             </a:extLst>
           </p:cNvPr>
@@ -5065,11 +5185,13 @@
         </p:nvSpPr>
         <p:spPr>
           <a:xfrm>
-            <a:off x="7455747" y="445702"/>
-            <a:ext cx="1380618" cy="662275"/>
+            <a:off x="7276915" y="1762873"/>
+            <a:ext cx="1757193" cy="1479801"/>
           </a:xfrm>
           <a:prstGeom prst="roundRect">
-            <a:avLst/>
+            <a:avLst>
+              <a:gd name="adj" fmla="val 6608"/>
+            </a:avLst>
           </a:prstGeom>
           <a:noFill/>
           <a:ln>
@@ -5102,194 +5224,23 @@
           <a:lstStyle/>
           <a:p>
             <a:pPr algn="ctr"/>
-            <a:r>
-              <a:rPr lang="en-US" dirty="0">
-                <a:solidFill>
-                  <a:schemeClr val="tx2">
-                    <a:lumMod val="25000"/>
-                    <a:lumOff val="75000"/>
-                  </a:schemeClr>
-                </a:solidFill>
-              </a:rPr>
-              <a:t>Xians Dev Portal</a:t>
-            </a:r>
-          </a:p>
-        </p:txBody>
-      </p:sp>
-      <p:cxnSp>
-        <p:nvCxnSpPr>
-          <p:cNvPr id="11" name="Straight Arrow Connector 10">
-            <a:extLst>
-              <a:ext uri="{FF2B5EF4-FFF2-40B4-BE49-F238E27FC236}">
-                <a16:creationId xmlns:a16="http://schemas.microsoft.com/office/drawing/2014/main" id="{71EFD1D8-E3BA-C484-7A4B-6E8BDBFECEEE}"/>
-              </a:ext>
-            </a:extLst>
-          </p:cNvPr>
-          <p:cNvCxnSpPr>
-            <a:cxnSpLocks/>
-          </p:cNvCxnSpPr>
-          <p:nvPr/>
-        </p:nvCxnSpPr>
-        <p:spPr>
-          <a:xfrm>
-            <a:off x="8142838" y="1191551"/>
-            <a:ext cx="0" cy="483541"/>
-          </a:xfrm>
-          <a:prstGeom prst="straightConnector1">
-            <a:avLst/>
-          </a:prstGeom>
-          <a:ln>
-            <a:solidFill>
-              <a:schemeClr val="tx2">
-                <a:lumMod val="25000"/>
-                <a:lumOff val="75000"/>
-              </a:schemeClr>
-            </a:solidFill>
-            <a:headEnd type="triangle"/>
-            <a:tailEnd type="triangle"/>
-          </a:ln>
-        </p:spPr>
-        <p:style>
-          <a:lnRef idx="2">
-            <a:schemeClr val="accent1"/>
-          </a:lnRef>
-          <a:fillRef idx="0">
-            <a:schemeClr val="accent1"/>
-          </a:fillRef>
-          <a:effectRef idx="1">
-            <a:schemeClr val="accent1"/>
-          </a:effectRef>
-          <a:fontRef idx="minor">
-            <a:schemeClr val="tx1"/>
-          </a:fontRef>
-        </p:style>
-      </p:cxnSp>
-      <p:cxnSp>
-        <p:nvCxnSpPr>
-          <p:cNvPr id="21" name="Straight Arrow Connector 20">
-            <a:extLst>
-              <a:ext uri="{FF2B5EF4-FFF2-40B4-BE49-F238E27FC236}">
-                <a16:creationId xmlns:a16="http://schemas.microsoft.com/office/drawing/2014/main" id="{F3B1EEF8-D976-3222-1850-BD993F1C4B63}"/>
-              </a:ext>
-            </a:extLst>
-          </p:cNvPr>
-          <p:cNvCxnSpPr/>
-          <p:nvPr/>
-        </p:nvCxnSpPr>
-        <p:spPr>
-          <a:xfrm>
-            <a:off x="2048438" y="2676433"/>
-            <a:ext cx="2701892" cy="0"/>
-          </a:xfrm>
-          <a:prstGeom prst="straightConnector1">
-            <a:avLst/>
-          </a:prstGeom>
-          <a:ln>
-            <a:solidFill>
-              <a:schemeClr val="bg1"/>
-            </a:solidFill>
-            <a:headEnd type="triangle"/>
-            <a:tailEnd type="triangle"/>
-          </a:ln>
-        </p:spPr>
-        <p:style>
-          <a:lnRef idx="2">
-            <a:schemeClr val="accent1"/>
-          </a:lnRef>
-          <a:fillRef idx="0">
-            <a:schemeClr val="accent1"/>
-          </a:fillRef>
-          <a:effectRef idx="1">
-            <a:schemeClr val="accent1"/>
-          </a:effectRef>
-          <a:fontRef idx="minor">
-            <a:schemeClr val="tx1"/>
-          </a:fontRef>
-        </p:style>
-      </p:cxnSp>
-      <p:pic>
-        <p:nvPicPr>
-          <p:cNvPr id="23" name="Graphic 22" descr="Ui Ux with solid fill">
-            <a:extLst>
-              <a:ext uri="{FF2B5EF4-FFF2-40B4-BE49-F238E27FC236}">
-                <a16:creationId xmlns:a16="http://schemas.microsoft.com/office/drawing/2014/main" id="{7585C4C5-A7E8-8C9B-DAC3-F27498D39667}"/>
-              </a:ext>
-            </a:extLst>
-          </p:cNvPr>
-          <p:cNvPicPr>
-            <a:picLocks noChangeAspect="1"/>
-          </p:cNvPicPr>
-          <p:nvPr/>
-        </p:nvPicPr>
-        <p:blipFill>
-          <a:blip r:embed="rId12">
-            <a:extLst>
-              <a:ext uri="{96DAC541-7B7A-43D3-8B79-37D633B846F1}">
-                <asvg:svgBlip xmlns:asvg="http://schemas.microsoft.com/office/drawing/2016/SVG/main" r:embed="rId13"/>
-              </a:ext>
-            </a:extLst>
-          </a:blip>
-          <a:stretch>
-            <a:fillRect/>
-          </a:stretch>
-        </p:blipFill>
-        <p:spPr>
-          <a:xfrm>
-            <a:off x="590705" y="2095009"/>
-            <a:ext cx="1237130" cy="1237130"/>
-          </a:xfrm>
-          <a:prstGeom prst="rect">
-            <a:avLst/>
-          </a:prstGeom>
-        </p:spPr>
-      </p:pic>
-      <p:sp>
-        <p:nvSpPr>
-          <p:cNvPr id="28" name="TextBox 27">
-            <a:extLst>
-              <a:ext uri="{FF2B5EF4-FFF2-40B4-BE49-F238E27FC236}">
-                <a16:creationId xmlns:a16="http://schemas.microsoft.com/office/drawing/2014/main" id="{5F3F082B-58F4-B7B2-9447-C2211B32FB7C}"/>
-              </a:ext>
-            </a:extLst>
-          </p:cNvPr>
-          <p:cNvSpPr txBox="1"/>
-          <p:nvPr/>
-        </p:nvSpPr>
-        <p:spPr>
-          <a:xfrm>
-            <a:off x="241082" y="3294997"/>
-            <a:ext cx="1936376" cy="276999"/>
-          </a:xfrm>
-          <a:prstGeom prst="rect">
-            <a:avLst/>
-          </a:prstGeom>
-          <a:noFill/>
-        </p:spPr>
-        <p:txBody>
-          <a:bodyPr wrap="square" rtlCol="0">
-            <a:spAutoFit/>
-          </a:bodyPr>
-          <a:lstStyle/>
-          <a:p>
-            <a:pPr algn="ctr"/>
-            <a:r>
-              <a:rPr lang="en-US" sz="1200" dirty="0">
-                <a:solidFill>
-                  <a:schemeClr val="bg1"/>
-                </a:solidFill>
-                <a:latin typeface="Avenir Book" panose="02000503020000020003" pitchFamily="2" charset="0"/>
-              </a:rPr>
-              <a:t>Your Product UI</a:t>
-            </a:r>
-          </a:p>
-        </p:txBody>
-      </p:sp>
-      <p:sp>
-        <p:nvSpPr>
-          <p:cNvPr id="29" name="Rounded Rectangle 28">
-            <a:extLst>
-              <a:ext uri="{FF2B5EF4-FFF2-40B4-BE49-F238E27FC236}">
-                <a16:creationId xmlns:a16="http://schemas.microsoft.com/office/drawing/2014/main" id="{5F2C60D7-94D4-FB7B-FC32-EDE8E37E900C}"/>
+            <a:endParaRPr lang="en-US" dirty="0">
+              <a:solidFill>
+                <a:schemeClr val="tx2">
+                  <a:lumMod val="25000"/>
+                  <a:lumOff val="75000"/>
+                </a:schemeClr>
+              </a:solidFill>
+            </a:endParaRPr>
+          </a:p>
+        </p:txBody>
+      </p:sp>
+      <p:sp>
+        <p:nvSpPr>
+          <p:cNvPr id="2" name="Rounded Rectangle 1">
+            <a:extLst>
+              <a:ext uri="{FF2B5EF4-FFF2-40B4-BE49-F238E27FC236}">
+                <a16:creationId xmlns:a16="http://schemas.microsoft.com/office/drawing/2014/main" id="{2AF94583-50B7-15DF-FF90-51C9C688B054}"/>
               </a:ext>
             </a:extLst>
           </p:cNvPr>
@@ -5298,13 +5249,11 @@
         </p:nvSpPr>
         <p:spPr>
           <a:xfrm>
-            <a:off x="7276915" y="1762873"/>
-            <a:ext cx="1757193" cy="1479801"/>
+            <a:off x="527440" y="445701"/>
+            <a:ext cx="1586753" cy="662275"/>
           </a:xfrm>
           <a:prstGeom prst="roundRect">
-            <a:avLst>
-              <a:gd name="adj" fmla="val 6608"/>
-            </a:avLst>
+            <a:avLst/>
           </a:prstGeom>
           <a:noFill/>
           <a:ln>
@@ -5337,68 +5286,6 @@
           <a:lstStyle/>
           <a:p>
             <a:pPr algn="ctr"/>
-            <a:endParaRPr lang="en-US" dirty="0">
-              <a:solidFill>
-                <a:schemeClr val="tx2">
-                  <a:lumMod val="25000"/>
-                  <a:lumOff val="75000"/>
-                </a:schemeClr>
-              </a:solidFill>
-            </a:endParaRPr>
-          </a:p>
-        </p:txBody>
-      </p:sp>
-      <p:sp>
-        <p:nvSpPr>
-          <p:cNvPr id="2" name="Rounded Rectangle 1">
-            <a:extLst>
-              <a:ext uri="{FF2B5EF4-FFF2-40B4-BE49-F238E27FC236}">
-                <a16:creationId xmlns:a16="http://schemas.microsoft.com/office/drawing/2014/main" id="{2AF94583-50B7-15DF-FF90-51C9C688B054}"/>
-              </a:ext>
-            </a:extLst>
-          </p:cNvPr>
-          <p:cNvSpPr/>
-          <p:nvPr/>
-        </p:nvSpPr>
-        <p:spPr>
-          <a:xfrm>
-            <a:off x="527440" y="445701"/>
-            <a:ext cx="1586753" cy="662275"/>
-          </a:xfrm>
-          <a:prstGeom prst="roundRect">
-            <a:avLst/>
-          </a:prstGeom>
-          <a:noFill/>
-          <a:ln>
-            <a:solidFill>
-              <a:schemeClr val="tx2">
-                <a:lumMod val="25000"/>
-                <a:lumOff val="75000"/>
-              </a:schemeClr>
-            </a:solidFill>
-          </a:ln>
-        </p:spPr>
-        <p:style>
-          <a:lnRef idx="2">
-            <a:schemeClr val="accent1">
-              <a:shade val="15000"/>
-            </a:schemeClr>
-          </a:lnRef>
-          <a:fillRef idx="1">
-            <a:schemeClr val="accent1"/>
-          </a:fillRef>
-          <a:effectRef idx="0">
-            <a:schemeClr val="accent1"/>
-          </a:effectRef>
-          <a:fontRef idx="minor">
-            <a:schemeClr val="lt1"/>
-          </a:fontRef>
-        </p:style>
-        <p:txBody>
-          <a:bodyPr rtlCol="0" anchor="ctr"/>
-          <a:lstStyle/>
-          <a:p>
-            <a:pPr algn="ctr"/>
             <a:r>
               <a:rPr lang="en-US" dirty="0">
                 <a:solidFill>
@@ -5483,11 +5370,11 @@
         <p:spPr>
           <a:xfrm>
             <a:off x="2352720" y="767110"/>
-            <a:ext cx="4771773" cy="1384248"/>
+            <a:ext cx="4707299" cy="1399367"/>
           </a:xfrm>
           <a:prstGeom prst="bentConnector3">
             <a:avLst>
-              <a:gd name="adj1" fmla="val 90776"/>
+              <a:gd name="adj1" fmla="val 86171"/>
             </a:avLst>
           </a:prstGeom>
           <a:ln>
@@ -5968,10 +5855,10 @@
           <p:nvPr/>
         </p:nvPicPr>
         <p:blipFill>
-          <a:blip r:embed="rId2">
+          <a:blip>
             <a:extLst>
               <a:ext uri="{96DAC541-7B7A-43D3-8B79-37D633B846F1}">
-                <asvg:svgBlip xmlns:asvg="http://schemas.microsoft.com/office/drawing/2016/SVG/main" r:embed="rId3"/>
+                <asvg:svgBlip xmlns:asvg="http://schemas.microsoft.com/office/drawing/2016/SVG/main" r:embed="rId2"/>
               </a:ext>
             </a:extLst>
           </a:blip>
@@ -6004,10 +5891,10 @@
           <p:nvPr/>
         </p:nvPicPr>
         <p:blipFill>
-          <a:blip r:embed="rId4">
+          <a:blip>
             <a:extLst>
               <a:ext uri="{96DAC541-7B7A-43D3-8B79-37D633B846F1}">
-                <asvg:svgBlip xmlns:asvg="http://schemas.microsoft.com/office/drawing/2016/SVG/main" r:embed="rId5"/>
+                <asvg:svgBlip xmlns:asvg="http://schemas.microsoft.com/office/drawing/2016/SVG/main" r:embed="rId3"/>
               </a:ext>
             </a:extLst>
           </a:blip>
@@ -6040,10 +5927,10 @@
           <p:nvPr/>
         </p:nvPicPr>
         <p:blipFill>
-          <a:blip r:embed="rId6">
+          <a:blip>
             <a:extLst>
               <a:ext uri="{96DAC541-7B7A-43D3-8B79-37D633B846F1}">
-                <asvg:svgBlip xmlns:asvg="http://schemas.microsoft.com/office/drawing/2016/SVG/main" r:embed="rId7"/>
+                <asvg:svgBlip xmlns:asvg="http://schemas.microsoft.com/office/drawing/2016/SVG/main" r:embed="rId4"/>
               </a:ext>
             </a:extLst>
           </a:blip>
@@ -6552,10 +6439,10 @@
           <p:nvPr/>
         </p:nvPicPr>
         <p:blipFill>
-          <a:blip r:embed="rId2">
+          <a:blip>
             <a:extLst>
               <a:ext uri="{96DAC541-7B7A-43D3-8B79-37D633B846F1}">
-                <asvg:svgBlip xmlns:asvg="http://schemas.microsoft.com/office/drawing/2016/SVG/main" r:embed="rId3"/>
+                <asvg:svgBlip xmlns:asvg="http://schemas.microsoft.com/office/drawing/2016/SVG/main" r:embed="rId2"/>
               </a:ext>
             </a:extLst>
           </a:blip>
@@ -6677,10 +6564,10 @@
           <p:nvPr/>
         </p:nvPicPr>
         <p:blipFill>
-          <a:blip r:embed="rId4">
+          <a:blip>
             <a:extLst>
               <a:ext uri="{96DAC541-7B7A-43D3-8B79-37D633B846F1}">
-                <asvg:svgBlip xmlns:asvg="http://schemas.microsoft.com/office/drawing/2016/SVG/main" r:embed="rId5"/>
+                <asvg:svgBlip xmlns:asvg="http://schemas.microsoft.com/office/drawing/2016/SVG/main" r:embed="rId3"/>
               </a:ext>
             </a:extLst>
           </a:blip>
@@ -6713,10 +6600,10 @@
           <p:nvPr/>
         </p:nvPicPr>
         <p:blipFill>
-          <a:blip r:embed="rId4">
+          <a:blip>
             <a:extLst>
               <a:ext uri="{96DAC541-7B7A-43D3-8B79-37D633B846F1}">
-                <asvg:svgBlip xmlns:asvg="http://schemas.microsoft.com/office/drawing/2016/SVG/main" r:embed="rId5"/>
+                <asvg:svgBlip xmlns:asvg="http://schemas.microsoft.com/office/drawing/2016/SVG/main" r:embed="rId3"/>
               </a:ext>
             </a:extLst>
           </a:blip>
@@ -7245,10 +7132,10 @@
           <p:nvPr/>
         </p:nvPicPr>
         <p:blipFill>
-          <a:blip r:embed="rId4">
+          <a:blip>
             <a:extLst>
               <a:ext uri="{96DAC541-7B7A-43D3-8B79-37D633B846F1}">
-                <asvg:svgBlip xmlns:asvg="http://schemas.microsoft.com/office/drawing/2016/SVG/main" r:embed="rId5"/>
+                <asvg:svgBlip xmlns:asvg="http://schemas.microsoft.com/office/drawing/2016/SVG/main" r:embed="rId3"/>
               </a:ext>
             </a:extLst>
           </a:blip>
@@ -7281,10 +7168,10 @@
           <p:nvPr/>
         </p:nvPicPr>
         <p:blipFill>
-          <a:blip r:embed="rId4">
+          <a:blip>
             <a:extLst>
               <a:ext uri="{96DAC541-7B7A-43D3-8B79-37D633B846F1}">
-                <asvg:svgBlip xmlns:asvg="http://schemas.microsoft.com/office/drawing/2016/SVG/main" r:embed="rId5"/>
+                <asvg:svgBlip xmlns:asvg="http://schemas.microsoft.com/office/drawing/2016/SVG/main" r:embed="rId3"/>
               </a:ext>
             </a:extLst>
           </a:blip>
@@ -7523,10 +7410,10 @@
           <p:nvPr/>
         </p:nvPicPr>
         <p:blipFill>
-          <a:blip r:embed="rId2">
+          <a:blip>
             <a:extLst>
               <a:ext uri="{96DAC541-7B7A-43D3-8B79-37D633B846F1}">
-                <asvg:svgBlip xmlns:asvg="http://schemas.microsoft.com/office/drawing/2016/SVG/main" r:embed="rId3"/>
+                <asvg:svgBlip xmlns:asvg="http://schemas.microsoft.com/office/drawing/2016/SVG/main" r:embed="rId2"/>
               </a:ext>
             </a:extLst>
           </a:blip>
@@ -7651,10 +7538,10 @@
           <p:nvPr/>
         </p:nvPicPr>
         <p:blipFill>
-          <a:blip r:embed="rId4">
+          <a:blip>
             <a:extLst>
               <a:ext uri="{96DAC541-7B7A-43D3-8B79-37D633B846F1}">
-                <asvg:svgBlip xmlns:asvg="http://schemas.microsoft.com/office/drawing/2016/SVG/main" r:embed="rId5"/>
+                <asvg:svgBlip xmlns:asvg="http://schemas.microsoft.com/office/drawing/2016/SVG/main" r:embed="rId3"/>
               </a:ext>
             </a:extLst>
           </a:blip>
@@ -7687,10 +7574,10 @@
           <p:nvPr/>
         </p:nvPicPr>
         <p:blipFill>
-          <a:blip r:embed="rId4">
+          <a:blip>
             <a:extLst>
               <a:ext uri="{96DAC541-7B7A-43D3-8B79-37D633B846F1}">
-                <asvg:svgBlip xmlns:asvg="http://schemas.microsoft.com/office/drawing/2016/SVG/main" r:embed="rId5"/>
+                <asvg:svgBlip xmlns:asvg="http://schemas.microsoft.com/office/drawing/2016/SVG/main" r:embed="rId3"/>
               </a:ext>
             </a:extLst>
           </a:blip>
@@ -8231,10 +8118,10 @@
           <p:nvPr/>
         </p:nvPicPr>
         <p:blipFill>
-          <a:blip r:embed="rId4">
+          <a:blip>
             <a:extLst>
               <a:ext uri="{96DAC541-7B7A-43D3-8B79-37D633B846F1}">
-                <asvg:svgBlip xmlns:asvg="http://schemas.microsoft.com/office/drawing/2016/SVG/main" r:embed="rId5"/>
+                <asvg:svgBlip xmlns:asvg="http://schemas.microsoft.com/office/drawing/2016/SVG/main" r:embed="rId3"/>
               </a:ext>
             </a:extLst>
           </a:blip>
@@ -8267,10 +8154,10 @@
           <p:nvPr/>
         </p:nvPicPr>
         <p:blipFill>
-          <a:blip r:embed="rId4">
+          <a:blip>
             <a:extLst>
               <a:ext uri="{96DAC541-7B7A-43D3-8B79-37D633B846F1}">
-                <asvg:svgBlip xmlns:asvg="http://schemas.microsoft.com/office/drawing/2016/SVG/main" r:embed="rId5"/>
+                <asvg:svgBlip xmlns:asvg="http://schemas.microsoft.com/office/drawing/2016/SVG/main" r:embed="rId3"/>
               </a:ext>
             </a:extLst>
           </a:blip>
@@ -8471,10 +8358,10 @@
           <p:nvPr/>
         </p:nvPicPr>
         <p:blipFill>
-          <a:blip r:embed="rId6">
+          <a:blip>
             <a:extLst>
               <a:ext uri="{96DAC541-7B7A-43D3-8B79-37D633B846F1}">
-                <asvg:svgBlip xmlns:asvg="http://schemas.microsoft.com/office/drawing/2016/SVG/main" r:embed="rId7"/>
+                <asvg:svgBlip xmlns:asvg="http://schemas.microsoft.com/office/drawing/2016/SVG/main" r:embed="rId4"/>
               </a:ext>
             </a:extLst>
           </a:blip>
@@ -8597,10 +8484,10 @@
           <p:nvPr/>
         </p:nvPicPr>
         <p:blipFill>
-          <a:blip r:embed="rId8">
+          <a:blip>
             <a:extLst>
               <a:ext uri="{96DAC541-7B7A-43D3-8B79-37D633B846F1}">
-                <asvg:svgBlip xmlns:asvg="http://schemas.microsoft.com/office/drawing/2016/SVG/main" r:embed="rId9"/>
+                <asvg:svgBlip xmlns:asvg="http://schemas.microsoft.com/office/drawing/2016/SVG/main" r:embed="rId5"/>
               </a:ext>
             </a:extLst>
           </a:blip>
@@ -8784,10 +8671,10 @@
           <p:nvPr/>
         </p:nvPicPr>
         <p:blipFill>
-          <a:blip r:embed="rId10">
+          <a:blip>
             <a:extLst>
               <a:ext uri="{96DAC541-7B7A-43D3-8B79-37D633B846F1}">
-                <asvg:svgBlip xmlns:asvg="http://schemas.microsoft.com/office/drawing/2016/SVG/main" r:embed="rId11"/>
+                <asvg:svgBlip xmlns:asvg="http://schemas.microsoft.com/office/drawing/2016/SVG/main" r:embed="rId6"/>
               </a:ext>
             </a:extLst>
           </a:blip>
@@ -8820,10 +8707,10 @@
           <p:nvPr/>
         </p:nvPicPr>
         <p:blipFill>
-          <a:blip r:embed="rId10">
+          <a:blip>
             <a:extLst>
               <a:ext uri="{96DAC541-7B7A-43D3-8B79-37D633B846F1}">
-                <asvg:svgBlip xmlns:asvg="http://schemas.microsoft.com/office/drawing/2016/SVG/main" r:embed="rId11"/>
+                <asvg:svgBlip xmlns:asvg="http://schemas.microsoft.com/office/drawing/2016/SVG/main" r:embed="rId6"/>
               </a:ext>
             </a:extLst>
           </a:blip>
@@ -9015,10 +8902,10 @@
           <p:nvPr/>
         </p:nvPicPr>
         <p:blipFill>
-          <a:blip r:embed="rId2">
+          <a:blip>
             <a:extLst>
               <a:ext uri="{96DAC541-7B7A-43D3-8B79-37D633B846F1}">
-                <asvg:svgBlip xmlns:asvg="http://schemas.microsoft.com/office/drawing/2016/SVG/main" r:embed="rId3"/>
+                <asvg:svgBlip xmlns:asvg="http://schemas.microsoft.com/office/drawing/2016/SVG/main" r:embed="rId2"/>
               </a:ext>
             </a:extLst>
           </a:blip>
@@ -9269,10 +9156,10 @@
           <p:nvPr/>
         </p:nvPicPr>
         <p:blipFill>
-          <a:blip r:embed="rId4">
+          <a:blip>
             <a:extLst>
               <a:ext uri="{96DAC541-7B7A-43D3-8B79-37D633B846F1}">
-                <asvg:svgBlip xmlns:asvg="http://schemas.microsoft.com/office/drawing/2016/SVG/main" r:embed="rId5"/>
+                <asvg:svgBlip xmlns:asvg="http://schemas.microsoft.com/office/drawing/2016/SVG/main" r:embed="rId3"/>
               </a:ext>
             </a:extLst>
           </a:blip>
@@ -9395,10 +9282,10 @@
           <p:nvPr/>
         </p:nvPicPr>
         <p:blipFill>
-          <a:blip r:embed="rId6">
+          <a:blip>
             <a:extLst>
               <a:ext uri="{96DAC541-7B7A-43D3-8B79-37D633B846F1}">
-                <asvg:svgBlip xmlns:asvg="http://schemas.microsoft.com/office/drawing/2016/SVG/main" r:embed="rId7"/>
+                <asvg:svgBlip xmlns:asvg="http://schemas.microsoft.com/office/drawing/2016/SVG/main" r:embed="rId4"/>
               </a:ext>
             </a:extLst>
           </a:blip>
@@ -9582,10 +9469,10 @@
           <p:nvPr/>
         </p:nvPicPr>
         <p:blipFill>
-          <a:blip r:embed="rId8">
+          <a:blip>
             <a:extLst>
               <a:ext uri="{96DAC541-7B7A-43D3-8B79-37D633B846F1}">
-                <asvg:svgBlip xmlns:asvg="http://schemas.microsoft.com/office/drawing/2016/SVG/main" r:embed="rId9"/>
+                <asvg:svgBlip xmlns:asvg="http://schemas.microsoft.com/office/drawing/2016/SVG/main" r:embed="rId5"/>
               </a:ext>
             </a:extLst>
           </a:blip>
@@ -9618,10 +9505,10 @@
           <p:nvPr/>
         </p:nvPicPr>
         <p:blipFill>
-          <a:blip r:embed="rId8">
+          <a:blip>
             <a:extLst>
               <a:ext uri="{96DAC541-7B7A-43D3-8B79-37D633B846F1}">
-                <asvg:svgBlip xmlns:asvg="http://schemas.microsoft.com/office/drawing/2016/SVG/main" r:embed="rId9"/>
+                <asvg:svgBlip xmlns:asvg="http://schemas.microsoft.com/office/drawing/2016/SVG/main" r:embed="rId5"/>
               </a:ext>
             </a:extLst>
           </a:blip>

</xml_diff>